<commit_message>
Ajout de tous les fichiers modifiés
</commit_message>
<xml_diff>
--- a/support de présentation/Support.pptx
+++ b/support de présentation/Support.pptx
@@ -16827,7 +16827,7 @@
           <a:p>
             <a:fld id="{DF066D4B-5B15-40DC-B79A-547796BF2ADF}" type="datetimeFigureOut">
               <a:rPr lang="fr-FR" smtClean="0"/>
-              <a:t>05/06/2025</a:t>
+              <a:t>11/06/2025</a:t>
             </a:fld>
             <a:endParaRPr lang="fr-FR"/>
           </a:p>
@@ -18017,7 +18017,7 @@
           <a:p>
             <a:fld id="{F6811082-672B-4758-B914-86DF1DD0B74E}" type="datetime1">
               <a:rPr lang="en-US" smtClean="0"/>
-              <a:t>6/5/2025</a:t>
+              <a:t>6/11/2025</a:t>
             </a:fld>
             <a:endParaRPr lang="en-US" dirty="0"/>
           </a:p>
@@ -19106,7 +19106,7 @@
           <a:p>
             <a:fld id="{05100506-B3D9-4843-BE8F-BE2BB580562A}" type="datetime1">
               <a:rPr lang="en-US" smtClean="0"/>
-              <a:t>6/5/2025</a:t>
+              <a:t>6/11/2025</a:t>
             </a:fld>
             <a:endParaRPr lang="en-US" dirty="0"/>
           </a:p>
@@ -20087,7 +20087,7 @@
           <a:p>
             <a:fld id="{996D5F45-7A3C-4173-8EF8-38FA75F914C7}" type="datetime1">
               <a:rPr lang="en-US" smtClean="0"/>
-              <a:t>6/5/2025</a:t>
+              <a:t>6/11/2025</a:t>
             </a:fld>
             <a:endParaRPr lang="en-US" dirty="0"/>
           </a:p>
@@ -21222,7 +21222,7 @@
           <a:p>
             <a:fld id="{88B86122-FD2C-40E7-B362-6453893EDE67}" type="datetime1">
               <a:rPr lang="en-US" smtClean="0"/>
-              <a:t>6/5/2025</a:t>
+              <a:t>6/11/2025</a:t>
             </a:fld>
             <a:endParaRPr lang="en-US" dirty="0"/>
           </a:p>
@@ -22257,7 +22257,7 @@
           <a:p>
             <a:fld id="{FE0C945E-682A-43C2-BB16-138A040B7766}" type="datetime1">
               <a:rPr lang="en-US" smtClean="0"/>
-              <a:t>6/5/2025</a:t>
+              <a:t>6/11/2025</a:t>
             </a:fld>
             <a:endParaRPr lang="en-US" dirty="0"/>
           </a:p>
@@ -22918,7 +22918,7 @@
           <a:p>
             <a:fld id="{F064B28D-0AEC-4EC2-97CB-75A996419966}" type="datetime1">
               <a:rPr lang="en-US" smtClean="0"/>
-              <a:t>6/5/2025</a:t>
+              <a:t>6/11/2025</a:t>
             </a:fld>
             <a:endParaRPr lang="en-US" dirty="0"/>
           </a:p>
@@ -23780,7 +23780,7 @@
           <a:p>
             <a:fld id="{8704C66B-F6C2-4DAD-B61E-3BAEE6863496}" type="datetime1">
               <a:rPr lang="en-US" smtClean="0"/>
-              <a:t>6/5/2025</a:t>
+              <a:t>6/11/2025</a:t>
             </a:fld>
             <a:endParaRPr lang="en-US" dirty="0"/>
           </a:p>
@@ -23971,7 +23971,7 @@
           <a:p>
             <a:fld id="{1D06B180-F7D4-4BE2-9BD7-AC529620EDF6}" type="datetime1">
               <a:rPr lang="en-US" smtClean="0"/>
-              <a:t>6/5/2025</a:t>
+              <a:t>6/11/2025</a:t>
             </a:fld>
             <a:endParaRPr lang="en-US" dirty="0"/>
           </a:p>
@@ -24944,7 +24944,7 @@
           <a:p>
             <a:fld id="{6F47B96B-E48D-4F3F-833F-94EC221DD7CA}" type="datetime1">
               <a:rPr lang="en-US" smtClean="0"/>
-              <a:t>6/5/2025</a:t>
+              <a:t>6/11/2025</a:t>
             </a:fld>
             <a:endParaRPr lang="en-US" dirty="0"/>
           </a:p>
@@ -25156,7 +25156,7 @@
           <a:p>
             <a:fld id="{B743388B-4EAB-45D5-A0BC-AB1A9E88EB3F}" type="datetime1">
               <a:rPr lang="en-US" smtClean="0"/>
-              <a:t>6/5/2025</a:t>
+              <a:t>6/11/2025</a:t>
             </a:fld>
             <a:endParaRPr lang="en-US" dirty="0"/>
           </a:p>
@@ -26191,7 +26191,7 @@
           <a:p>
             <a:fld id="{C67AA2C5-782E-4122-ADC5-0E20CD362AEE}" type="datetime1">
               <a:rPr lang="en-US" smtClean="0"/>
-              <a:t>6/5/2025</a:t>
+              <a:t>6/11/2025</a:t>
             </a:fld>
             <a:endParaRPr lang="en-US" dirty="0"/>
           </a:p>
@@ -26464,7 +26464,7 @@
           <a:p>
             <a:fld id="{D66FF5CC-F53A-488B-A8A0-6BAA6820932B}" type="datetime1">
               <a:rPr lang="en-US" smtClean="0"/>
-              <a:t>6/5/2025</a:t>
+              <a:t>6/11/2025</a:t>
             </a:fld>
             <a:endParaRPr lang="en-US" dirty="0"/>
           </a:p>
@@ -26875,7 +26875,7 @@
           <a:p>
             <a:fld id="{739D0124-1F72-4887-8BDC-639778E763ED}" type="datetime1">
               <a:rPr lang="en-US" smtClean="0"/>
-              <a:t>6/5/2025</a:t>
+              <a:t>6/11/2025</a:t>
             </a:fld>
             <a:endParaRPr lang="en-US" dirty="0"/>
           </a:p>
@@ -27003,7 +27003,7 @@
           <a:p>
             <a:fld id="{4145D4F3-6474-46E6-A19C-3CA0ABBDCF69}" type="datetime1">
               <a:rPr lang="en-US" smtClean="0"/>
-              <a:t>6/5/2025</a:t>
+              <a:t>6/11/2025</a:t>
             </a:fld>
             <a:endParaRPr lang="en-US" dirty="0"/>
           </a:p>
@@ -27099,7 +27099,7 @@
           <a:p>
             <a:fld id="{CB769F71-5F80-4812-8408-6BE327A5D76F}" type="datetime1">
               <a:rPr lang="en-US" smtClean="0"/>
-              <a:t>6/5/2025</a:t>
+              <a:t>6/11/2025</a:t>
             </a:fld>
             <a:endParaRPr lang="en-US" dirty="0"/>
           </a:p>
@@ -28181,7 +28181,7 @@
           <a:p>
             <a:fld id="{565DCA41-D932-4827-80D5-8651D25F4897}" type="datetime1">
               <a:rPr lang="en-US" smtClean="0"/>
-              <a:t>6/5/2025</a:t>
+              <a:t>6/11/2025</a:t>
             </a:fld>
             <a:endParaRPr lang="en-US" dirty="0"/>
           </a:p>
@@ -29290,7 +29290,7 @@
           <a:p>
             <a:fld id="{91569438-CB00-469F-B950-7C952ED2F74A}" type="datetime1">
               <a:rPr lang="en-US" smtClean="0"/>
-              <a:t>6/5/2025</a:t>
+              <a:t>6/11/2025</a:t>
             </a:fld>
             <a:endParaRPr lang="en-US" dirty="0"/>
           </a:p>
@@ -30288,7 +30288,7 @@
           <a:p>
             <a:fld id="{88B86122-FD2C-40E7-B362-6453893EDE67}" type="datetime1">
               <a:rPr lang="en-US" smtClean="0"/>
-              <a:t>6/5/2025</a:t>
+              <a:t>6/11/2025</a:t>
             </a:fld>
             <a:endParaRPr lang="en-US" dirty="0"/>
           </a:p>
@@ -31453,7 +31453,7 @@
         </p:nvSpPr>
         <p:spPr>
           <a:xfrm>
-            <a:off x="-42959" y="677497"/>
+            <a:off x="0" y="712033"/>
             <a:ext cx="12192000" cy="6145967"/>
           </a:xfrm>
           <a:solidFill>
@@ -32174,14 +32174,14 @@
           <p:nvPr>
             <p:extLst>
               <p:ext uri="{D42A27DB-BD31-4B8C-83A1-F6EECF244321}">
-                <p14:modId xmlns:p14="http://schemas.microsoft.com/office/powerpoint/2010/main" val="829997925"/>
+                <p14:modId xmlns:p14="http://schemas.microsoft.com/office/powerpoint/2010/main" val="1368694321"/>
               </p:ext>
             </p:extLst>
           </p:nvPr>
         </p:nvGraphicFramePr>
         <p:xfrm>
-          <a:off x="257750" y="4385334"/>
-          <a:ext cx="2964130" cy="785526"/>
+          <a:off x="257749" y="4694738"/>
+          <a:ext cx="2964130" cy="770489"/>
         </p:xfrm>
         <a:graphic>
           <a:graphicData uri="http://schemas.openxmlformats.org/drawingml/2006/table">
@@ -32203,7 +32203,7 @@
                   </a:extLst>
                 </a:gridCol>
               </a:tblGrid>
-              <a:tr h="421130">
+              <a:tr h="423792">
                 <a:tc rowSpan="2">
                   <a:txBody>
                     <a:bodyPr/>
@@ -32217,7 +32217,7 @@
                           <a:latin typeface="Yu Gothic" panose="020B0400000000000000" pitchFamily="34" charset="-128"/>
                           <a:ea typeface="Yu Gothic" panose="020B0400000000000000" pitchFamily="34" charset="-128"/>
                         </a:rPr>
-                        <a:t>Classe prédite</a:t>
+                        <a:t>Classe réelle</a:t>
                       </a:r>
                     </a:p>
                   </a:txBody>
@@ -32307,7 +32307,7 @@
                   </a:ext>
                 </a:extLst>
               </a:tr>
-              <a:tr h="364396">
+              <a:tr h="346697">
                 <a:tc vMerge="1">
                   <a:txBody>
                     <a:bodyPr/>
@@ -32418,14 +32418,14 @@
           <p:nvPr>
             <p:extLst>
               <p:ext uri="{D42A27DB-BD31-4B8C-83A1-F6EECF244321}">
-                <p14:modId xmlns:p14="http://schemas.microsoft.com/office/powerpoint/2010/main" val="897846759"/>
+                <p14:modId xmlns:p14="http://schemas.microsoft.com/office/powerpoint/2010/main" val="2902487585"/>
               </p:ext>
             </p:extLst>
           </p:nvPr>
         </p:nvGraphicFramePr>
         <p:xfrm>
-          <a:off x="3221879" y="3650953"/>
-          <a:ext cx="2571367" cy="1519907"/>
+          <a:off x="3221879" y="3992846"/>
+          <a:ext cx="2571367" cy="1472381"/>
         </p:xfrm>
         <a:graphic>
           <a:graphicData uri="http://schemas.openxmlformats.org/drawingml/2006/table">
@@ -32447,7 +32447,7 @@
                   </a:extLst>
                 </a:gridCol>
               </a:tblGrid>
-              <a:tr h="352326">
+              <a:tr h="0">
                 <a:tc gridSpan="2">
                   <a:txBody>
                     <a:bodyPr/>
@@ -32462,7 +32462,7 @@
                           <a:latin typeface="Yu Gothic" panose="020B0400000000000000" pitchFamily="34" charset="-128"/>
                           <a:ea typeface="Yu Gothic" panose="020B0400000000000000" pitchFamily="34" charset="-128"/>
                         </a:rPr>
-                        <a:t>Classe réelle</a:t>
+                        <a:t>Classe prédite</a:t>
                       </a:r>
                     </a:p>
                   </a:txBody>
@@ -34192,7 +34192,7 @@
                 <a:latin typeface="Yu Gothic" panose="020B0400000000000000" pitchFamily="34" charset="-128"/>
                 <a:ea typeface="Yu Gothic" panose="020B0400000000000000" pitchFamily="34" charset="-128"/>
               </a:rPr>
-              <a:t>3. ('sampling', SMOTE()) </a:t>
+              <a:t>3. ('sampling', SMOTE())  pour LGBM </a:t>
             </a:r>
             <a:r>
               <a:rPr lang="fr-FR" sz="1400" dirty="0">
@@ -38352,13 +38352,13 @@
           <p:nvPr>
             <p:extLst>
               <p:ext uri="{D42A27DB-BD31-4B8C-83A1-F6EECF244321}">
-                <p14:modId xmlns:p14="http://schemas.microsoft.com/office/powerpoint/2010/main" val="2358559400"/>
+                <p14:modId xmlns:p14="http://schemas.microsoft.com/office/powerpoint/2010/main" val="4070596010"/>
               </p:ext>
             </p:extLst>
           </p:nvPr>
         </p:nvGraphicFramePr>
         <p:xfrm>
-          <a:off x="0" y="774700"/>
+          <a:off x="0" y="733425"/>
           <a:ext cx="12192000" cy="6083298"/>
         </p:xfrm>
         <a:graphic>
@@ -40081,73 +40081,6 @@
               <a:buNone/>
             </a:pPr>
             <a:r>
-              <a:rPr lang="fr-FR" dirty="0">
-                <a:solidFill>
-                  <a:prstClr val="black">
-                    <a:lumMod val="75000"/>
-                    <a:lumOff val="25000"/>
-                  </a:prstClr>
-                </a:solidFill>
-                <a:latin typeface="Yu Gothic" panose="020B0400000000000000" pitchFamily="34" charset="-128"/>
-                <a:ea typeface="Yu Gothic" panose="020B0400000000000000" pitchFamily="34" charset="-128"/>
-              </a:rPr>
-              <a:t>	❑ </a:t>
-            </a:r>
-            <a:r>
-              <a:rPr lang="fr-FR" b="1" dirty="0">
-                <a:latin typeface="Yu Gothic" panose="020B0400000000000000" pitchFamily="34" charset="-128"/>
-                <a:ea typeface="Yu Gothic" panose="020B0400000000000000" pitchFamily="34" charset="-128"/>
-              </a:rPr>
-              <a:t>Application web : </a:t>
-            </a:r>
-            <a:r>
-              <a:rPr lang="fr-FR" b="1" dirty="0">
-                <a:solidFill>
-                  <a:srgbClr val="0070C0"/>
-                </a:solidFill>
-                <a:latin typeface="Yu Gothic" panose="020B0400000000000000" pitchFamily="34" charset="-128"/>
-                <a:ea typeface="Yu Gothic" panose="020B0400000000000000" pitchFamily="34" charset="-128"/>
-                <a:hlinkClick r:id="rId3">
-                  <a:extLst>
-                    <a:ext uri="{A12FA001-AC4F-418D-AE19-62706E023703}">
-                      <ahyp:hlinkClr xmlns:ahyp="http://schemas.microsoft.com/office/drawing/2018/hyperlinkcolor" val="tx"/>
-                    </a:ext>
-                  </a:extLst>
-                </a:hlinkClick>
-              </a:rPr>
-              <a:t>http://solvability-env-1.eba-3sirvjbb.eu-west-3.elasticbeanstalk.com/</a:t>
-            </a:r>
-            <a:endParaRPr lang="fr-FR" b="1" dirty="0">
-              <a:solidFill>
-                <a:srgbClr val="0070C0"/>
-              </a:solidFill>
-              <a:latin typeface="Yu Gothic" panose="020B0400000000000000" pitchFamily="34" charset="-128"/>
-              <a:ea typeface="Yu Gothic" panose="020B0400000000000000" pitchFamily="34" charset="-128"/>
-            </a:endParaRPr>
-          </a:p>
-          <a:p>
-            <a:pPr marL="0" indent="0">
-              <a:buNone/>
-            </a:pPr>
-            <a:endParaRPr lang="fr-FR" dirty="0">
-              <a:latin typeface="Yu Gothic" panose="020B0400000000000000" pitchFamily="34" charset="-128"/>
-              <a:ea typeface="Yu Gothic" panose="020B0400000000000000" pitchFamily="34" charset="-128"/>
-            </a:endParaRPr>
-          </a:p>
-          <a:p>
-            <a:pPr marL="0" indent="0">
-              <a:buNone/>
-            </a:pPr>
-            <a:endParaRPr lang="fr-FR" dirty="0">
-              <a:latin typeface="Yu Gothic" panose="020B0400000000000000" pitchFamily="34" charset="-128"/>
-              <a:ea typeface="Yu Gothic" panose="020B0400000000000000" pitchFamily="34" charset="-128"/>
-            </a:endParaRPr>
-          </a:p>
-          <a:p>
-            <a:pPr marL="0" indent="0">
-              <a:buNone/>
-            </a:pPr>
-            <a:r>
               <a:rPr kumimoji="0" lang="fr-FR" sz="1800" b="0" i="0" u="none" strike="noStrike" kern="1200" cap="none" spc="0" normalizeH="0" baseline="0" noProof="0" dirty="0">
                 <a:ln>
                   <a:noFill/>
@@ -40207,7 +40140,7 @@
                 </a:solidFill>
                 <a:latin typeface="Yu Gothic" panose="020B0400000000000000" pitchFamily="34" charset="-128"/>
                 <a:ea typeface="Yu Gothic" panose="020B0400000000000000" pitchFamily="34" charset="-128"/>
-                <a:hlinkClick r:id="rId4">
+                <a:hlinkClick r:id="rId3">
                   <a:extLst>
                     <a:ext uri="{A12FA001-AC4F-418D-AE19-62706E023703}">
                       <ahyp:hlinkClr xmlns:ahyp="http://schemas.microsoft.com/office/drawing/2018/hyperlinkcolor" val="tx"/>
@@ -40224,7 +40157,7 @@
                 </a:solidFill>
                 <a:latin typeface="Yu Gothic" panose="020B0400000000000000" pitchFamily="34" charset="-128"/>
                 <a:ea typeface="Yu Gothic" panose="020B0400000000000000" pitchFamily="34" charset="-128"/>
-                <a:hlinkClick r:id="rId3">
+                <a:hlinkClick r:id="rId4">
                   <a:extLst>
                     <a:ext uri="{A12FA001-AC4F-418D-AE19-62706E023703}">
                       <ahyp:hlinkClr xmlns:ahyp="http://schemas.microsoft.com/office/drawing/2018/hyperlinkcolor" val="tx"/>
@@ -40417,7 +40350,7 @@
                 </a:solidFill>
                 <a:latin typeface="Yu Gothic" panose="020B0400000000000000" pitchFamily="34" charset="-128"/>
                 <a:ea typeface="Yu Gothic" panose="020B0400000000000000" pitchFamily="34" charset="-128"/>
-                <a:hlinkClick r:id="rId3">
+                <a:hlinkClick r:id="rId4">
                   <a:extLst>
                     <a:ext uri="{A12FA001-AC4F-418D-AE19-62706E023703}">
                       <ahyp:hlinkClr xmlns:ahyp="http://schemas.microsoft.com/office/drawing/2018/hyperlinkcolor" val="tx"/>
@@ -40444,6 +40377,60 @@
               </a:rPr>
               <a:t>(non exposé publiquement)</a:t>
             </a:r>
+          </a:p>
+          <a:p>
+            <a:pPr marL="0" indent="0">
+              <a:buNone/>
+            </a:pPr>
+            <a:endParaRPr lang="fr-FR" dirty="0">
+              <a:solidFill>
+                <a:prstClr val="black">
+                  <a:lumMod val="75000"/>
+                  <a:lumOff val="25000"/>
+                </a:prstClr>
+              </a:solidFill>
+              <a:latin typeface="Yu Gothic" panose="020B0400000000000000" pitchFamily="34" charset="-128"/>
+              <a:ea typeface="Yu Gothic" panose="020B0400000000000000" pitchFamily="34" charset="-128"/>
+            </a:endParaRPr>
+          </a:p>
+          <a:p>
+            <a:pPr marL="0" indent="0">
+              <a:buNone/>
+            </a:pPr>
+            <a:r>
+              <a:rPr lang="fr-FR" dirty="0">
+                <a:solidFill>
+                  <a:prstClr val="black">
+                    <a:lumMod val="75000"/>
+                    <a:lumOff val="25000"/>
+                  </a:prstClr>
+                </a:solidFill>
+                <a:latin typeface="Yu Gothic" panose="020B0400000000000000" pitchFamily="34" charset="-128"/>
+                <a:ea typeface="Yu Gothic" panose="020B0400000000000000" pitchFamily="34" charset="-128"/>
+              </a:rPr>
+              <a:t>	❑ </a:t>
+            </a:r>
+            <a:r>
+              <a:rPr lang="fr-FR" b="1" dirty="0">
+                <a:latin typeface="Yu Gothic" panose="020B0400000000000000" pitchFamily="34" charset="-128"/>
+                <a:ea typeface="Yu Gothic" panose="020B0400000000000000" pitchFamily="34" charset="-128"/>
+              </a:rPr>
+              <a:t>Api déployé : </a:t>
+            </a:r>
+            <a:r>
+              <a:rPr lang="fr-FR" b="1" u="sng" dirty="0">
+                <a:solidFill>
+                  <a:srgbClr val="0070C0"/>
+                </a:solidFill>
+                <a:latin typeface="Yu Gothic" panose="020B0400000000000000" pitchFamily="34" charset="-128"/>
+                <a:ea typeface="Yu Gothic" panose="020B0400000000000000" pitchFamily="34" charset="-128"/>
+              </a:rPr>
+              <a:t>http://solvability-env-1.eba-3sirvjbb.eu-west-3.elasticbeanstalk.com/docs </a:t>
+            </a:r>
+            <a:endParaRPr lang="fr-FR" u="sng" dirty="0">
+              <a:latin typeface="Yu Gothic" panose="020B0400000000000000" pitchFamily="34" charset="-128"/>
+              <a:ea typeface="Yu Gothic" panose="020B0400000000000000" pitchFamily="34" charset="-128"/>
+            </a:endParaRPr>
           </a:p>
           <a:p>
             <a:pPr marL="0" indent="0">

</xml_diff>